<commit_message>
Mise à jour Kayak : modifications et suppressions de fichiers
</commit_message>
<xml_diff>
--- a/1-Construire et gérer une infrastructure de données/Projet-Planifiez votre voyage avec Kayak/Kayak_Story_slides.pptx
+++ b/1-Construire et gérer une infrastructure de données/Projet-Planifiez votre voyage avec Kayak/Kayak_Story_slides.pptx
@@ -1386,7 +1386,7 @@
                 <a:ea typeface="Calibri" pitchFamily="34" charset="-122"/>
                 <a:cs typeface="Calibri" pitchFamily="34" charset="-120"/>
               </a:rPr>
-              <a:t>souhaitent plus d'informations sur leur destination avant de réserver. </a:t>
+              <a:t xml:space="preserve">souhaitent plus d'informations sur leur destination avant de réserver. </a:t>
             </a:r>
           </a:p>
           <a:p>
@@ -2529,7 +2529,7 @@
                 <a:ea typeface="Calibri" pitchFamily="34" charset="-122"/>
                 <a:cs typeface="Calibri" pitchFamily="34" charset="-120"/>
               </a:rPr>
-              <a:t>6 fichiers CSV</a:t>
+              <a:t>6 CSV générés</a:t>
             </a:r>
             <a:endParaRPr lang="en-US" sz="1100" dirty="0"/>
           </a:p>
@@ -2568,7 +2568,7 @@
                 <a:ea typeface="Calibri" pitchFamily="34" charset="-122"/>
                 <a:cs typeface="Calibri" pitchFamily="34" charset="-120"/>
               </a:rPr>
-              <a:t>générés par le pipeline</a:t>
+              <a:t>dont 4 sur AWS S3</a:t>
             </a:r>
             <a:endParaRPr lang="en-US" sz="1000" dirty="0"/>
           </a:p>
@@ -3384,7 +3384,7 @@
                 <a:ea typeface="Calibri" pitchFamily="34" charset="-122"/>
                 <a:cs typeface="Calibri" pitchFamily="34" charset="-120"/>
               </a:rPr>
-              <a:t>6</a:t>
+              <a:t>4</a:t>
             </a:r>
             <a:endParaRPr lang="en-US" sz="3000" dirty="0"/>
           </a:p>
@@ -3423,7 +3423,7 @@
                 <a:ea typeface="Calibri" pitchFamily="34" charset="-122"/>
                 <a:cs typeface="Calibri" pitchFamily="34" charset="-120"/>
               </a:rPr>
-              <a:t>fichiers CSV</a:t>
+              <a:t>CSV uploadés</a:t>
             </a:r>
             <a:endParaRPr lang="en-US" sz="900" dirty="0"/>
           </a:p>
@@ -4351,7 +4351,7 @@
                 <a:ea typeface="Calibri" pitchFamily="34" charset="-122"/>
                 <a:cs typeface="Calibri" pitchFamily="34" charset="-120"/>
               </a:rPr>
-              <a:t>35 villes + GPS · 2 Ko</a:t>
+              <a:t>35 villes + GPS · local uniquement</a:t>
             </a:r>
             <a:endParaRPr lang="en-US" sz="800" dirty="0"/>
           </a:p>
@@ -4713,7 +4713,7 @@
                 <a:ea typeface="Calibri" pitchFamily="34" charset="-122"/>
                 <a:cs typeface="Calibri" pitchFamily="34" charset="-120"/>
               </a:rPr>
-              <a:t>Données brutes · 51 Ko</a:t>
+              <a:t>Données brutes · local uniquement</a:t>
             </a:r>
             <a:endParaRPr lang="en-US" sz="800" dirty="0"/>
           </a:p>
@@ -5841,7 +5841,7 @@
                 <a:ea typeface="Calibri" pitchFamily="34" charset="-122"/>
                 <a:cs typeface="Calibri" pitchFamily="34" charset="-120"/>
               </a:rPr>
-              <a:t>Température (50 %) : </a:t>
+              <a:t xml:space="preserve">Température (50 %) : </a:t>
             </a:r>
             <a:r>
               <a:rPr lang="en-US" sz="950" dirty="0">
@@ -5864,7 +5864,7 @@
                 <a:ea typeface="Calibri" pitchFamily="34" charset="-122"/>
                 <a:cs typeface="Calibri" pitchFamily="34" charset="-120"/>
               </a:rPr>
-              <a:t>Note hôtelière (50 %) : </a:t>
+              <a:t xml:space="preserve">Note hôtelière (50 %) : </a:t>
             </a:r>
             <a:r>
               <a:rPr lang="en-US" sz="950" dirty="0">
@@ -5887,7 +5887,7 @@
                 <a:ea typeface="Calibri" pitchFamily="34" charset="-122"/>
                 <a:cs typeface="Calibri" pitchFamily="34" charset="-120"/>
               </a:rPr>
-              <a:t>Pondération ajustable </a:t>
+              <a:t xml:space="preserve">Pondération ajustable </a:t>
             </a:r>
             <a:r>
               <a:rPr lang="en-US" sz="950" dirty="0">
@@ -5969,7 +5969,7 @@
                 <a:ea typeface="Calibri" pitchFamily="34" charset="-122"/>
                 <a:cs typeface="Calibri" pitchFamily="34" charset="-120"/>
               </a:rPr>
-              <a:t>Cloud : AWS S3 (6 CSV · boto3) · AWS RDS PostgreSQL (2 tables · SQLAlchemy)  |  Score : travel_score = (temp × 0.5) + (note × 2 × 0.5)</a:t>
+              <a:t>Cloud : AWS S3 (4 CSV uploadés · boto3) · AWS RDS PostgreSQL (2 tables · SQLAlchemy)  |  Score : travel_score = (temp × 0.5) + (note × 2 × 0.5)</a:t>
             </a:r>
             <a:endParaRPr lang="en-US" sz="850" dirty="0">
               <a:solidFill>
@@ -6803,7 +6803,7 @@
                 <a:ea typeface="Calibri" pitchFamily="34" charset="-122"/>
                 <a:cs typeface="Calibri" pitchFamily="34" charset="-120"/>
               </a:rPr>
-              <a:t>6</a:t>
+              <a:t>4</a:t>
             </a:r>
             <a:endParaRPr lang="en-US" sz="2800" dirty="0"/>
           </a:p>

</xml_diff>